<commit_message>
feat: homework/assessment/grading/diagnostics mechanisms close the learning loop (Phase C)
</commit_message>
<xml_diff>
--- a/work/备课/选择性必修下册/氓/_v6_stage/prototypes/04P_氓_V6三类页面视觉原型.pptx
+++ b/work/备课/选择性必修下册/氓/_v6_stage/prototypes/04P_氓_V6三类页面视觉原型.pptx
@@ -504,30 +504,30 @@
           <a:p>
             <a:r>
               <a:rPr lang="en-US" dirty="0"/>
-              <a:t>【V6页ID】N003｜把四个人的故事放在一起｜3分钟
+              <a:t>【V6页ID】N003｜四个人，把记得的故事说给彼此听｜6分钟
 【教师逐字稿】
-每组自己定一号，再沿一个方向排出二、三、四号；从一号开始依次轮说，一个都不少。轮到你时，用十五到二十秒说清篇名和它写了什么。听别人说时，遇到自己原先没想到的作品或主题，就在个人听记处勾下来。四轮结束，有勾项的，从中圈出最想带进全班的一项；如果三轮都没有新增，就如实勾‘暂无新增’，再从小组作品谱里圈一项值得全班听见的。请一位同学执笔，记下全组的篇名和主题短语；轮到执笔人发言时，由下一位替他记。作品重复没有关系，能补出不同的主题就接着说。最后我会给每组一张空白磁贴卡，请用四十秒写清一篇的篇名和‘它写了什么’，交给下一轮发言的代表。
+四个人先沿一个方向定一、二、三、四号，再选一位执笔人。等我说开始，一号先说，依次轮到四号，一个都不少。轮到你，只需二十秒：报篇名，用一句平常话说它写了什么；听别人时，听见自己没想到的作品或意思，就在旁边勾一下。执笔人只记篇名和短语，轮到自己时由下一位代记。（等待四轮完成。）现在每个人圈两项想带进全班的内容；没有新增，也请如实勾‘暂无新增’，再从全组作品谱里选两项。比较四个人的圈选，每组领取两张贡献卡，分别写清‘篇名＋它写了什么’，再补上组号、卡号和最初说出这项内容的同学号码，请这位同学亲手写卡或在卡上签认。尽量让两张卡来自两位同学；若两项确实都来自同一人，就如实写同一个号码。
 【场面与走位】
-四人小组围绕一张小组作品谱坐定；每组自定一号，沿一个方向排出二至四号，再按号依次轮说。屏幕显示1→2→3→4，以及轮到我、听别人和执笔人的真实关系，不固定高亮任何一号。空白磁贴卡先留在教师手中。
-（各组自定一号并沿一个方向编号）
-（启动3分钟计时）
-（巡视听者是否遇到新内容即勾记）
-（四轮后确认有勾项者圈一项、暂无新增者从作品谱圈一项）
-（轮到执笔人时提示下一位代记）
-（轮说后每组分发一张空白磁贴卡）
-（确认代表拿到写好的卡）
+四人小组围绕一张作品谱坐定。屏幕突出编号轮说、说者与听者动作，以及本页最终要留下的两张贡献卡。教师先把全部口令说完再计时，空白贡献卡在轮说结束后发下。
+（各组定号并选执笔人）
+（口令说完后启动六分钟计时）
+（巡视四人是否逐一开口）
+（确认听者边听边勾）
+（四轮后每人圈两项）
+（分发两张带来源栏的贡献卡）
+（核对原提议者号与签认后交代表）
 【时间盒】
-说明三种角色：25秒；四人轮说：80秒；追补重复作品的不同主题：25秒；分发并写成全班贡献卡：40秒；确认代表持卡：10秒
+定号、选执笔人与听清口令：45秒；四人轮说与同步听记：100秒；执笔人补齐小组作品谱：35秒；每人圈两项或诚实标暂无新增：40秒；比较圈选并书写两张带来源贡献卡：105秒；原提议者签认并交代表：35秒
 【现场分支】
 duplicate_work：四人说到同一篇时，不强迫换作品；教师提示‘可以补一个前面没有说到的主题，但仍只用自然话。’
 memory_blank：仍无作品者先完整听一位同伴，再从听到的作品中选一篇写下自己记得的情节；不允许同伴代写。
 one_student_dominates：有人超时详讲时，教师轻点计时器说‘先把这一篇留在二十秒里，让下一位也有声音。’
 【听者同步任务】
-听见自己未想到的作品或主题就勾；四轮结束后，有勾项者从中圈一项，暂无新增者如实标记并从小组作品谱圈一项。执笔人只写篇名和短语，轮到自己发言时由下一位代记。
+听见自己未想到的作品或主题就勾；四轮结束后，每人留下两项选择，暂无新增者如实标记并从小组作品谱选择两项。执笔人只写篇名和短语，轮到自己发言时由下一位代记；入选内容由原提议者写卡或签认。
 【证据位置】
-学习单A·小组作品谱；空白磁贴卡·全组贡献卡
+学习单A·小组作品谱、个人两项圈选与贡献卡来源；两张带组号－卡号－原提议者号－签认栏的磁贴贡献卡
 【自然切页句】
-四个人的作品谱已经成形。每组挑一张，让全班看见新的故事。
+四个人的作品谱已经成形。每组带着两张卡，让全班看见更宽的故事版图。
 【声明边界】桌面排演稿；不声称真实学生已经理解、参与或学会。</a:t>
             </a:r>
             <a:endParaRPr lang="en-US" dirty="0"/>
@@ -730,23 +730,24 @@
               <a:rPr lang="en-US" dirty="0"/>
               <a:t>【V6页ID】N012｜先借四言节奏走进声音｜2分钟
 【教师逐字稿】
-知道谁在说，还要先把她的话读顺。斜线只提示基本节奏，不能把‘抱布贸丝’这样的完整动作切碎。先看屏幕，听我读前两句，大家跟读一遍。等我说‘看教材’，再把目光移到教材第一章开头的无斜线原句。现在，看教材。同桌互读；听者若听见机械的一字一顿，就问‘谁做什么’，读者带着完整动作再读一遍。最后在路标卡上写下你重读后改动的一处。
+知道谁在说，还要先把她的话读顺。斜线只提示基本节奏，不能把‘抱布贸丝’这样的动作切碎。先看屏幕，听我读前两句，大家跟读一遍。现在，看教材。同桌互读一次，再诚实选择一条路：若停顿需要调整，听者只问‘谁做什么’，读者带着完整动作再读，并标出改动；若原本已经读顺，不必故意改错，请圈出一句里的连续动作，再完整读给同桌听。两条路都在读懂声音，不分高低。
 【场面与走位】
 屏幕以两行带节奏斜线的原诗为绝对视觉中心，并明示斜线不切碎动作。第一次跟读后，教师说出约定触发词‘看教材’，学生转到教材第一章开头的无斜线原句，再由听者提问、读者重读。
 （教师范读）
 （全班看屏幕跟读）
 （教师明确说‘看教材’）
-（学生转看教材第一章开头的无斜线原句）
-（听者用‘谁做什么’提问）
-（读者带完整动作重读）
-（学生在路标卡写下改动）
+（学生转看无斜线原句）
+（同桌判断需要调整或原本读顺）
+（分别完成修订或连续动作圈画）
+（双方重读）
 【时间盒】
-教师范读并提示两字一停：25秒；全班跟读：20秒；同桌互读与反馈：50秒；写下节奏改动并再次齐读：25秒
+教师范读并说明斜线用途：25秒；全班跟读：20秒；转看教材并同桌互读：35秒；两条诚实路径的反馈与标记：25秒；双方带着语意重读：15秒
 【现场分支】
 mechanical_pause：学生一字一顿时，听者不直接读答案，只问‘谁做什么？’让说者带完整动作重读。
+already_fluent：学生原本读顺时，不要求制造修改；请他圈出‘抱—贸’或‘来—谋’等连续动作，并把动作关系读给同桌听。
 word_question：有人追问‘蚩蚩、贸丝’时，教师说‘问题留下，下一步就在这两句里逐词解决’，不打断本页节奏体验。
 【听者同步任务】
-指出一处机械停顿，用‘谁做什么’帮助同桌保持语意后再读。
+先诚实判断同桌是否需要调整；需要时用‘谁做什么’帮助重读，原本读顺时复述自己听见的连续动作。
 【证据位置】
 学习单B·第一章节奏标记
 【自然切页句】

</xml_diff>